<commit_message>
docs: audit and synchronize all system design, architecture, pitch, and deck files with 13,511 vacancies, 36-district cascade, and 6 CTS bridge courses
</commit_message>
<xml_diff>
--- a/SIH26134-PERCEPTRON-KaushalSetu.pptx
+++ b/SIH26134-PERCEPTRON-KaushalSetu.pptx
@@ -16990,7 +16990,7 @@
               <a:rPr sz="2400">
                 <a:latin typeface="Calibri"/>
               </a:rPr>
-              <a:t>• Triangulated Demand Sensing (Job Portals + MIDC CapEx + MSME Voice)</a:t>
+              <a:t>• Triangulated Demand Sensing across 13,511 real Maharashtra vacancies</a:t>
             </a:r>
           </a:p>
           <a:p>
@@ -20687,7 +20687,7 @@
           <a:lstStyle/>
           <a:p>
             <a:r>
-              <a:t>TRAINING DATASET: Mahaswayam + MIDC Corpus</a:t>
+              <a:t>DATASET: 13,511 Verified MH Vacancies</a:t>
             </a:r>
           </a:p>
         </p:txBody>

</xml_diff>